<commit_message>
Day3 g6_estrogen: polish deck — compact cards, fix label contrast, divider notes, notes-PDF handout
</commit_message>
<xml_diff>
--- a/solutions/g6_estrogen/slides/g6_estrogen.pptx
+++ b/solutions/g6_estrogen/slides/g6_estrogen.pptx
@@ -7,7 +7,7 @@
   <p:sldIdLst>
     <p:sldId id="256" r:id="rId7"/>
     <p:sldId id="257" r:id="rId8"/>
-    <p:sldId id="258" r:id="rId9"/>
+    <p:sldId id="258" r:id="rId10"/>
     <p:sldId id="259" r:id="rId11"/>
     <p:sldId id="260" r:id="rId12"/>
     <p:sldId id="261" r:id="rId13"/>
@@ -523,7 +523,7 @@
               <a:rPr b="1" sz="1300">
                 <a:latin typeface="Geist Mono"/>
               </a:rPr>
-              <a:t>A twenty-year detective story</a:t>
+              <a:t>Background</a:t>
             </a:r>
           </a:p>
           <a:p>
@@ -531,7 +531,7 @@
               <a:rPr b="0" sz="1100">
                 <a:latin typeface="Geist"/>
               </a:rPr>
-              <a:t>Open like a mystery, because it was one. For twenty years, observational studies -- just watching women, not assigning anything -- kept finding that estrogen users had sharper memory and less Alzheimer's [1, 2]. Doctors nearly started prescribing hormones for the brain. Then in 2003 the WHIMS randomized trial flipped a coin to decide who got hormones, and the benefit didn't just vanish, it reversed: dementia risk actually rose [3, 4]. Same drug, opposite answer. Set up the whole talk as: how can two honest studies disagree this badly? Transition: here it is in one picture.</a:t>
+              <a:t>This opens the Background section. Everything ahead sets up the central mystery: how could years of just watching women and a single coin-flip trial reach opposite conclusions about the very same hormones? For now keep the audience curious, not yet informed. Transition: start with the twenty-year detective story.</a:t>
             </a:r>
           </a:p>
         </p:txBody>
@@ -604,15 +604,7 @@
               <a:rPr b="1" sz="1300">
                 <a:latin typeface="Geist Mono"/>
               </a:rPr>
-              <a:t>The tests say “fine”; she says “not fine”</a:t>
-            </a:r>
-          </a:p>
-          <a:p>
-            <a:r>
-              <a:rPr b="0" sz="1100">
-                <a:latin typeface="Geist"/>
-              </a:rPr>
-              <a:t>Step outside the numbers. Our data is a test SCORE. But many women in menopause report real, daily 'brain fog' even when their objective test looks normal [7] -- the slope lines cross exactly there. And women's symptoms get waved off as stress far too often [8]. The grown-up data-scientist stance holds two true things at once: the confounding is real (the pill may not be the hero), AND the patient's lived report is real evidence, not noise. Transition: so what can this project honestly claim?</a:t>
+              <a:t>The tempting headline, exactly as anyone would first compute it. Average the memory score for users versus non-users: 51.8 versus 43.7, an 8-point head start for the estrogen group. If you stopped here, you'd write 'estrogen users think better' -- the same clue the 1990s studies chased. The whole point of the next slide is that we did NOT stop here. Transition: now adjust for who these women were.</a:t>
             </a:r>
           </a:p>
         </p:txBody>
@@ -685,7 +677,7 @@
               <a:rPr b="1" sz="1300">
                 <a:latin typeface="Geist Mono"/>
               </a:rPr>
-              <a:t>A survey can hint; only an experiment proves</a:t>
+              <a:t>Two-thirds of the effect was confounding</a:t>
             </a:r>
           </a:p>
           <a:p>
@@ -693,7 +685,7 @@
               <a:rPr b="0" sz="1100">
                 <a:latin typeface="Geist"/>
               </a:rPr>
-              <a:t>Be scrupulously honest about scope -- this is what earns trust. CAN DO: show a tempting headline is mostly a mirage and that adjusting shrinks it ~67%. CANNOT DO: prove cause -- we can only correct for confounders we measured and thought of; something unrecorded could still be doing the work. SETTLES IT: a randomized trial, where a coin flip (not the patient) assigns the drug, so the groups start identical. That's why WHIMS could do what twenty years of watching couldn't. Transition: the sources.</a:t>
+              <a:t>The punchline slide. Same data, honest test. Crude effect: about -0.33 (negative = looks protective). Adjusted for age, education, and income: it collapses to -0.11. That's a 67% shrink -- two-thirds of the 'benefit' was never the estrogen, it was that users were healthier and better-off to begin with. This is confounding caught in the act, a miniature of exactly why WHIMS overturned the observational headlines. If they remember one number from this talk, make it 67%. Transition: one more check any people-model needs.</a:t>
             </a:r>
           </a:p>
         </p:txBody>
@@ -766,7 +758,7 @@
               <a:rPr b="1" sz="1300">
                 <a:latin typeface="Geist Mono"/>
               </a:rPr>
-              <a:t>References</a:t>
+              <a:t>Does the model work for everyone?</a:t>
             </a:r>
           </a:p>
           <a:p>
@@ -774,7 +766,7 @@
               <a:rPr b="0" sz="1100">
                 <a:latin typeface="Geist"/>
               </a:rPr>
-              <a:t>The paper trail, in order of the story. Top-left: the two observational studies that raised the exciting clue [1, 2]. Bottom of the left column into the trial: the WHIMS randomized results that overturned it [3, 4]. Right column: the healthy-user-bias explanation [5, 6] and the brain-fog / symptom-dismissal pieces [7, 8]. All were checked against PubMed or the journal page. Transition: one habit to take with you.</a:t>
+              <a:t>A fairness audit, the habit from earlier this week. We trained one model to predict low cognition, then split its accuracy by group: 0.73 for estrogen-users, 0.65 for non-users. A model can look fine overall yet work unequally across groups -- and a clinic that trusts it equally could quietly do more harm to the group it's worse at. The mature move isn't to hide the gap; it's to name it. Transition: and there's something no score in this dataset can see at all.</a:t>
             </a:r>
           </a:p>
         </p:txBody>
@@ -847,6 +839,330 @@
               <a:rPr b="1" sz="1300">
                 <a:latin typeface="Geist Mono"/>
               </a:rPr>
+              <a:t>What the numbers can’t capture</a:t>
+            </a:r>
+          </a:p>
+          <a:p>
+            <a:r>
+              <a:rPr b="0" sz="1100">
+                <a:latin typeface="Geist"/>
+              </a:rPr>
+              <a:t>This opens the final section, the honest limits. We step outside the numbers: a test score can say 'fine' while a woman lives with real daily brain fog, and a survey can only hint at cause, never prove it. Framing: good science names what it cannot do. Transition: the tests say fine; she says not fine.</a:t>
+            </a:r>
+          </a:p>
+        </p:txBody>
+      </p:sp>
+      <p:sp>
+        <p:nvSpPr>
+          <p:cNvPr id="4" name="Slide Number Placeholder 3"/>
+          <p:cNvSpPr>
+            <a:spLocks noGrp="1"/>
+          </p:cNvSpPr>
+          <p:nvPr>
+            <p:ph type="sldNum" idx="5" sz="quarter"/>
+          </p:nvPr>
+        </p:nvSpPr>
+        <p:spPr/>
+      </p:sp>
+    </p:spTree>
+  </p:cSld>
+  <p:clrMapOvr>
+    <a:masterClrMapping/>
+  </p:clrMapOvr>
+</p:notes>
+</file>
+
+<file path=ppt/notesSlides/notesSlide14.xml><?xml version="1.0" encoding="utf-8"?>
+<p:notes xmlns:a="http://schemas.openxmlformats.org/drawingml/2006/main" xmlns:p="http://schemas.openxmlformats.org/presentationml/2006/main" xmlns:r="http://schemas.openxmlformats.org/officeDocument/2006/relationships">
+  <p:cSld>
+    <p:spTree>
+      <p:nvGrpSpPr>
+        <p:cNvPr id="1" name=""/>
+        <p:cNvGrpSpPr/>
+        <p:nvPr/>
+      </p:nvGrpSpPr>
+      <p:grpSpPr>
+        <a:xfrm>
+          <a:off x="0" y="0"/>
+          <a:ext cx="0" cy="0"/>
+          <a:chOff x="0" y="0"/>
+          <a:chExt cx="0" cy="0"/>
+        </a:xfrm>
+      </p:grpSpPr>
+      <p:sp>
+        <p:nvSpPr>
+          <p:cNvPr id="2" name="Slide Image Placeholder 1"/>
+          <p:cNvSpPr>
+            <a:spLocks noGrp="1"/>
+          </p:cNvSpPr>
+          <p:nvPr>
+            <p:ph type="sldImg" idx="2"/>
+          </p:nvPr>
+        </p:nvSpPr>
+        <p:spPr/>
+      </p:sp>
+      <p:sp>
+        <p:nvSpPr>
+          <p:cNvPr id="3" name="Notes Placeholder 2"/>
+          <p:cNvSpPr>
+            <a:spLocks noGrp="1"/>
+          </p:cNvSpPr>
+          <p:nvPr>
+            <p:ph type="body" idx="3" sz="quarter"/>
+          </p:nvPr>
+        </p:nvSpPr>
+        <p:spPr/>
+        <p:txBody>
+          <a:bodyPr/>
+          <a:lstStyle/>
+          <a:p>
+            <a:r>
+              <a:rPr b="1" sz="1300">
+                <a:latin typeface="Geist Mono"/>
+              </a:rPr>
+              <a:t>The tests say “fine”; she says “not fine”</a:t>
+            </a:r>
+          </a:p>
+          <a:p>
+            <a:r>
+              <a:rPr b="0" sz="1100">
+                <a:latin typeface="Geist"/>
+              </a:rPr>
+              <a:t>Step outside the numbers. Our data is a test SCORE. But many women in menopause report real, daily 'brain fog' even when their objective test looks normal [7] -- the slope lines cross exactly there. And women's symptoms get waved off as stress far too often [8]. The grown-up data-scientist stance holds two true things at once: the confounding is real (the pill may not be the hero), AND the patient's lived report is real evidence, not noise. Transition: so what can this project honestly claim?</a:t>
+            </a:r>
+          </a:p>
+        </p:txBody>
+      </p:sp>
+      <p:sp>
+        <p:nvSpPr>
+          <p:cNvPr id="4" name="Slide Number Placeholder 3"/>
+          <p:cNvSpPr>
+            <a:spLocks noGrp="1"/>
+          </p:cNvSpPr>
+          <p:nvPr>
+            <p:ph type="sldNum" idx="5" sz="quarter"/>
+          </p:nvPr>
+        </p:nvSpPr>
+        <p:spPr/>
+      </p:sp>
+    </p:spTree>
+  </p:cSld>
+  <p:clrMapOvr>
+    <a:masterClrMapping/>
+  </p:clrMapOvr>
+</p:notes>
+</file>
+
+<file path=ppt/notesSlides/notesSlide15.xml><?xml version="1.0" encoding="utf-8"?>
+<p:notes xmlns:a="http://schemas.openxmlformats.org/drawingml/2006/main" xmlns:p="http://schemas.openxmlformats.org/presentationml/2006/main" xmlns:r="http://schemas.openxmlformats.org/officeDocument/2006/relationships">
+  <p:cSld>
+    <p:spTree>
+      <p:nvGrpSpPr>
+        <p:cNvPr id="1" name=""/>
+        <p:cNvGrpSpPr/>
+        <p:nvPr/>
+      </p:nvGrpSpPr>
+      <p:grpSpPr>
+        <a:xfrm>
+          <a:off x="0" y="0"/>
+          <a:ext cx="0" cy="0"/>
+          <a:chOff x="0" y="0"/>
+          <a:chExt cx="0" cy="0"/>
+        </a:xfrm>
+      </p:grpSpPr>
+      <p:sp>
+        <p:nvSpPr>
+          <p:cNvPr id="2" name="Slide Image Placeholder 1"/>
+          <p:cNvSpPr>
+            <a:spLocks noGrp="1"/>
+          </p:cNvSpPr>
+          <p:nvPr>
+            <p:ph type="sldImg" idx="2"/>
+          </p:nvPr>
+        </p:nvSpPr>
+        <p:spPr/>
+      </p:sp>
+      <p:sp>
+        <p:nvSpPr>
+          <p:cNvPr id="3" name="Notes Placeholder 2"/>
+          <p:cNvSpPr>
+            <a:spLocks noGrp="1"/>
+          </p:cNvSpPr>
+          <p:nvPr>
+            <p:ph type="body" idx="3" sz="quarter"/>
+          </p:nvPr>
+        </p:nvSpPr>
+        <p:spPr/>
+        <p:txBody>
+          <a:bodyPr/>
+          <a:lstStyle/>
+          <a:p>
+            <a:r>
+              <a:rPr b="1" sz="1300">
+                <a:latin typeface="Geist Mono"/>
+              </a:rPr>
+              <a:t>A survey can hint; only an experiment proves</a:t>
+            </a:r>
+          </a:p>
+          <a:p>
+            <a:r>
+              <a:rPr b="0" sz="1100">
+                <a:latin typeface="Geist"/>
+              </a:rPr>
+              <a:t>Be scrupulously honest about scope -- this is what earns trust. CAN DO: show a tempting headline is mostly a mirage and that adjusting shrinks it ~67%. CANNOT DO: prove cause -- we can only correct for confounders we measured and thought of; something unrecorded could still be doing the work. SETTLES IT: a randomized trial, where a coin flip (not the patient) assigns the drug, so the groups start identical. That's why WHIMS could do what twenty years of watching couldn't. Transition: the sources.</a:t>
+            </a:r>
+          </a:p>
+        </p:txBody>
+      </p:sp>
+      <p:sp>
+        <p:nvSpPr>
+          <p:cNvPr id="4" name="Slide Number Placeholder 3"/>
+          <p:cNvSpPr>
+            <a:spLocks noGrp="1"/>
+          </p:cNvSpPr>
+          <p:nvPr>
+            <p:ph type="sldNum" idx="5" sz="quarter"/>
+          </p:nvPr>
+        </p:nvSpPr>
+        <p:spPr/>
+      </p:sp>
+    </p:spTree>
+  </p:cSld>
+  <p:clrMapOvr>
+    <a:masterClrMapping/>
+  </p:clrMapOvr>
+</p:notes>
+</file>
+
+<file path=ppt/notesSlides/notesSlide16.xml><?xml version="1.0" encoding="utf-8"?>
+<p:notes xmlns:a="http://schemas.openxmlformats.org/drawingml/2006/main" xmlns:p="http://schemas.openxmlformats.org/presentationml/2006/main" xmlns:r="http://schemas.openxmlformats.org/officeDocument/2006/relationships">
+  <p:cSld>
+    <p:spTree>
+      <p:nvGrpSpPr>
+        <p:cNvPr id="1" name=""/>
+        <p:cNvGrpSpPr/>
+        <p:nvPr/>
+      </p:nvGrpSpPr>
+      <p:grpSpPr>
+        <a:xfrm>
+          <a:off x="0" y="0"/>
+          <a:ext cx="0" cy="0"/>
+          <a:chOff x="0" y="0"/>
+          <a:chExt cx="0" cy="0"/>
+        </a:xfrm>
+      </p:grpSpPr>
+      <p:sp>
+        <p:nvSpPr>
+          <p:cNvPr id="2" name="Slide Image Placeholder 1"/>
+          <p:cNvSpPr>
+            <a:spLocks noGrp="1"/>
+          </p:cNvSpPr>
+          <p:nvPr>
+            <p:ph type="sldImg" idx="2"/>
+          </p:nvPr>
+        </p:nvSpPr>
+        <p:spPr/>
+      </p:sp>
+      <p:sp>
+        <p:nvSpPr>
+          <p:cNvPr id="3" name="Notes Placeholder 2"/>
+          <p:cNvSpPr>
+            <a:spLocks noGrp="1"/>
+          </p:cNvSpPr>
+          <p:nvPr>
+            <p:ph type="body" idx="3" sz="quarter"/>
+          </p:nvPr>
+        </p:nvSpPr>
+        <p:spPr/>
+        <p:txBody>
+          <a:bodyPr/>
+          <a:lstStyle/>
+          <a:p>
+            <a:r>
+              <a:rPr b="1" sz="1300">
+                <a:latin typeface="Geist Mono"/>
+              </a:rPr>
+              <a:t>References</a:t>
+            </a:r>
+          </a:p>
+          <a:p>
+            <a:r>
+              <a:rPr b="0" sz="1100">
+                <a:latin typeface="Geist"/>
+              </a:rPr>
+              <a:t>The paper trail, in order of the story. Top-left: the two observational studies that raised the exciting clue [1, 2]. Bottom of the left column into the trial: the WHIMS randomized results that overturned it [3, 4]. Right column: the healthy-user-bias explanation [5, 6] and the brain-fog / symptom-dismissal pieces [7, 8]. All were checked against PubMed or the journal page. Transition: one habit to take with you.</a:t>
+            </a:r>
+          </a:p>
+        </p:txBody>
+      </p:sp>
+      <p:sp>
+        <p:nvSpPr>
+          <p:cNvPr id="4" name="Slide Number Placeholder 3"/>
+          <p:cNvSpPr>
+            <a:spLocks noGrp="1"/>
+          </p:cNvSpPr>
+          <p:nvPr>
+            <p:ph type="sldNum" idx="5" sz="quarter"/>
+          </p:nvPr>
+        </p:nvSpPr>
+        <p:spPr/>
+      </p:sp>
+    </p:spTree>
+  </p:cSld>
+  <p:clrMapOvr>
+    <a:masterClrMapping/>
+  </p:clrMapOvr>
+</p:notes>
+</file>
+
+<file path=ppt/notesSlides/notesSlide17.xml><?xml version="1.0" encoding="utf-8"?>
+<p:notes xmlns:a="http://schemas.openxmlformats.org/drawingml/2006/main" xmlns:p="http://schemas.openxmlformats.org/presentationml/2006/main" xmlns:r="http://schemas.openxmlformats.org/officeDocument/2006/relationships">
+  <p:cSld>
+    <p:spTree>
+      <p:nvGrpSpPr>
+        <p:cNvPr id="1" name=""/>
+        <p:cNvGrpSpPr/>
+        <p:nvPr/>
+      </p:nvGrpSpPr>
+      <p:grpSpPr>
+        <a:xfrm>
+          <a:off x="0" y="0"/>
+          <a:ext cx="0" cy="0"/>
+          <a:chOff x="0" y="0"/>
+          <a:chExt cx="0" cy="0"/>
+        </a:xfrm>
+      </p:grpSpPr>
+      <p:sp>
+        <p:nvSpPr>
+          <p:cNvPr id="2" name="Slide Image Placeholder 1"/>
+          <p:cNvSpPr>
+            <a:spLocks noGrp="1"/>
+          </p:cNvSpPr>
+          <p:nvPr>
+            <p:ph type="sldImg" idx="2"/>
+          </p:nvPr>
+        </p:nvSpPr>
+        <p:spPr/>
+      </p:sp>
+      <p:sp>
+        <p:nvSpPr>
+          <p:cNvPr id="3" name="Notes Placeholder 2"/>
+          <p:cNvSpPr>
+            <a:spLocks noGrp="1"/>
+          </p:cNvSpPr>
+          <p:nvPr>
+            <p:ph type="body" idx="3" sz="quarter"/>
+          </p:nvPr>
+        </p:nvSpPr>
+        <p:spPr/>
+        <p:txBody>
+          <a:bodyPr/>
+          <a:lstStyle/>
+          <a:p>
+            <a:r>
+              <a:rPr b="1" sz="1300">
+                <a:latin typeface="Geist Mono"/>
+              </a:rPr>
               <a:t>The one habit to carry out the door</a:t>
             </a:r>
           </a:p>
@@ -928,7 +1244,7 @@
               <a:rPr b="1" sz="1300">
                 <a:latin typeface="Geist Mono"/>
               </a:rPr>
-              <a:t>When they flipped a coin, the benefit vanished</a:t>
+              <a:t>A twenty-year detective story</a:t>
             </a:r>
           </a:p>
           <a:p>
@@ -936,7 +1252,7 @@
               <a:rPr b="0" sz="1100">
                 <a:latin typeface="Geist"/>
               </a:rPr>
-              <a:t>This is our most important slide -- read it slowly. Left bar, 'just watching': hormone users looked protected, risk about two-thirds of non-users. Right bar, the coin-flip trial: risk more than doubled. The amber arrow is the sign flip. The dashed line is 'no effect.' The point for a 15-year-old: the STUDY DESIGN, not the drug, decided the answer. Watching can lie; a coin flip cannot. Transition: so why does watching lie here?</a:t>
+              <a:t>Open like a mystery, because it was one. For twenty years, observational studies -- just watching women, not assigning anything -- kept finding that estrogen users had sharper memory and less Alzheimer's [1, 2]. Doctors nearly started prescribing hormones for the brain. Then in 2003 the WHIMS randomized trial flipped a coin to decide who got hormones, and the benefit didn't just vanish, it reversed: dementia risk actually rose [3, 4]. Same drug, opposite answer. Set up the whole talk as: how can two honest studies disagree this badly? Transition: here it is in one picture.</a:t>
             </a:r>
           </a:p>
         </p:txBody>
@@ -1009,7 +1325,7 @@
               <a:rPr b="1" sz="1300">
                 <a:latin typeface="Geist Mono"/>
               </a:rPr>
-              <a:t>Healthy-user bias: a hidden third factor</a:t>
+              <a:t>When they flipped a coin, the benefit vanished</a:t>
             </a:r>
           </a:p>
           <a:p>
@@ -1017,7 +1333,7 @@
               <a:rPr b="0" sz="1100">
                 <a:latin typeface="Geist"/>
               </a:rPr>
-              <a:t>Now name the villain: confounding, or 'healthy-user bias.' The women who chose hormone therapy were, on average, richer, more active, and saw doctors more [5]. That hidden head start -- the pink box at the top -- pushes down on BOTH boxes: it makes them more likely to take the pill AND more likely to have good memory. So the dashed bottom arrow, 'takes pill -&gt; better memory,' only LOOKS like cause. It's a mirage created by the third factor [6]. This one diagram is the whole statistical idea of the talk. Transition: you already know this trap from summer.</a:t>
+              <a:t>This is our most important slide -- read it slowly. Left bar, 'just watching': hormone users looked protected, risk about two-thirds of non-users. Right bar, the coin-flip trial: risk more than doubled. The amber arrow is the sign flip. The dashed line is 'no effect.' The point for a 15-year-old: the STUDY DESIGN, not the drug, decided the answer. Watching can lie; a coin flip cannot. Transition: so why does watching lie here?</a:t>
             </a:r>
           </a:p>
         </p:txBody>
@@ -1090,7 +1406,7 @@
               <a:rPr b="1" sz="1300">
                 <a:latin typeface="Geist Mono"/>
               </a:rPr>
-              <a:t>Ice cream and shark attacks</a:t>
+              <a:t>Healthy-user bias: a hidden third factor</a:t>
             </a:r>
           </a:p>
           <a:p>
@@ -1098,7 +1414,7 @@
               <a:rPr b="0" sz="1100">
                 <a:latin typeface="Geist"/>
               </a:rPr>
-              <a:t>Make it click with the classic. Ice-cream sales and shark attacks rise together every summer -- but ice cream doesn't summon sharks; hot weather drives both. Map it: estrogen use is the ice cream, good memory is the shark attacks, and 'being healthier to start with' is the summer heat. The takeaway line is the transferable habit: when two things move together, hunt for the hidden third factor before you believe one caused the other. Transition: now to our own toy data.</a:t>
+              <a:t>Now name the villain: confounding, or 'healthy-user bias.' The women who chose hormone therapy were, on average, richer, more active, and saw doctors more [5]. That hidden head start -- the pink box at the top -- pushes down on BOTH boxes: it makes them more likely to take the pill AND more likely to have good memory. So the dashed bottom arrow, 'takes pill -&gt; better memory,' only LOOKS like cause. It's a mirage created by the third factor [6]. This one diagram is the whole statistical idea of the talk. Transition: you already know this trap from summer.</a:t>
             </a:r>
           </a:p>
         </p:txBody>
@@ -1171,7 +1487,7 @@
               <a:rPr b="1" sz="1300">
                 <a:latin typeface="Geist Mono"/>
               </a:rPr>
-              <a:t>Our data: NHANES women 60 and older</a:t>
+              <a:t>Ice cream and shark attacks</a:t>
             </a:r>
           </a:p>
           <a:p>
@@ -1179,7 +1495,7 @@
               <a:rPr b="0" sz="1100">
                 <a:latin typeface="Geist"/>
               </a:rPr>
-              <a:t>Quick tour of the dataset so the results land. 739 women, all 60+, from NHANES -- a real US government health survey, not something we made up. For each woman we know: did she ever use estrogen; her age, education, and income (the possible confounders); and a memory/attention test score, where higher is sharper. Our model tries to predict who lands in the weaker-scoring half. Keep it light -- they don't need every column, just the shape. Transition: what can we actually ask of survey data?</a:t>
+              <a:t>Make it click with the classic. Ice-cream sales and shark attacks rise together every summer -- but ice cream doesn't summon sharks; hot weather drives both. Map it: estrogen use is the ice cream, good memory is the shark attacks, and 'being healthier to start with' is the summer heat. The takeaway line is the transferable habit: when two things move together, hunt for the hidden third factor before you believe one caused the other. Transition: now to our own toy data.</a:t>
             </a:r>
           </a:p>
         </p:txBody>
@@ -1252,7 +1568,7 @@
               <a:rPr b="1" sz="1300">
                 <a:latin typeface="Geist Mono"/>
               </a:rPr>
-              <a:t>The one question we can actually ask</a:t>
+              <a:t>Methods</a:t>
             </a:r>
           </a:p>
           <a:p>
@@ -1260,7 +1576,7 @@
               <a:rPr b="0" sz="1100">
                 <a:latin typeface="Geist"/>
               </a:rPr>
-              <a:t>Set expectations honestly. We can't randomly assign estrogen in a survey -- so we can't prove cause. But we CAN ask the narrower question in the box: does the estrogen effect survive once we account for age, education, and income? We'll measure estrogen's effect two ways -- crude (alone) and adjusted (after the confounders). If it shrinks, the crude headline was mostly confounding. That crude-vs-adjusted move is the entire method. Transition: start with the naive, tempting look.</a:t>
+              <a:t>This opens the Methods section. We move from the big idea -- confounding -- to the concrete: the actual survey data we used and the one honest question a survey can answer. Plain-language framing: here is exactly what we looked at, and what we can fairly ask of it. Transition: meet the dataset.</a:t>
             </a:r>
           </a:p>
         </p:txBody>
@@ -1333,7 +1649,15 @@
               <a:rPr b="1" sz="1300">
                 <a:latin typeface="Geist Mono"/>
               </a:rPr>
-              <a:t>The tempting headline, exactly as anyone would first compute it. Average the memory score for users versus non-users: 51.8 versus 43.7, an 8-point head start for the estrogen group. If you stopped here, you'd write 'estrogen users think better' -- the same clue the 1990s studies chased. The whole point of the next slide is that we did NOT stop here. Transition: now adjust for who these women were.</a:t>
+              <a:t>Our data: NHANES women 60 and older</a:t>
+            </a:r>
+          </a:p>
+          <a:p>
+            <a:r>
+              <a:rPr b="0" sz="1100">
+                <a:latin typeface="Geist"/>
+              </a:rPr>
+              <a:t>Quick tour of the dataset so the results land. 739 women, all 60+, from NHANES -- a real US government health survey, not something we made up. For each woman we know: did she ever use estrogen; her age, education, and income (the possible confounders); and a memory/attention test score, where higher is sharper. Our model tries to predict who lands in the weaker-scoring half. Keep it light -- they don't need every column, just the shape. Transition: what can we actually ask of survey data?</a:t>
             </a:r>
           </a:p>
         </p:txBody>
@@ -1406,7 +1730,7 @@
               <a:rPr b="1" sz="1300">
                 <a:latin typeface="Geist Mono"/>
               </a:rPr>
-              <a:t>Two-thirds of the effect was confounding</a:t>
+              <a:t>The one question we can actually ask</a:t>
             </a:r>
           </a:p>
           <a:p>
@@ -1414,7 +1738,7 @@
               <a:rPr b="0" sz="1100">
                 <a:latin typeface="Geist"/>
               </a:rPr>
-              <a:t>The punchline slide. Same data, honest test. Crude effect: about -0.33 (negative = looks protective). Adjusted for age, education, and income: it collapses to -0.11. That's a 67% shrink -- two-thirds of the 'benefit' was never the estrogen, it was that users were healthier and better-off to begin with. This is confounding caught in the act, a miniature of exactly why WHIMS overturned the observational headlines. If they remember one number from this talk, make it 67%. Transition: one more check any people-model needs.</a:t>
+              <a:t>Set expectations honestly. We can't randomly assign estrogen in a survey -- so we can't prove cause. But we CAN ask the narrower question in the box: does the estrogen effect survive once we account for age, education, and income? We'll measure estrogen's effect two ways -- crude (alone) and adjusted (after the confounders). If it shrinks, the crude headline was mostly confounding. That crude-vs-adjusted move is the entire method. Transition: start with the naive, tempting look.</a:t>
             </a:r>
           </a:p>
         </p:txBody>
@@ -1487,7 +1811,7 @@
               <a:rPr b="1" sz="1300">
                 <a:latin typeface="Geist Mono"/>
               </a:rPr>
-              <a:t>Does the model work for everyone?</a:t>
+              <a:t>Results</a:t>
             </a:r>
           </a:p>
           <a:p>
@@ -1495,7 +1819,7 @@
               <a:rPr b="0" sz="1100">
                 <a:latin typeface="Geist"/>
               </a:rPr>
-              <a:t>A fairness audit, the habit from earlier this week. We trained one model to predict low cognition, then split its accuracy by group: 0.73 for estrogen-users, 0.65 for non-users. A model can look fine overall yet work unequally across groups -- and a clinic that trusts it equally could quietly do more harm to the group it's worse at. The mature move isn't to hide the gap; it's to name it. Transition: and there's something no score in this dataset can see at all.</a:t>
+              <a:t>This opens the Results section, the payoff. Three slides ahead: the tempting raw headline, the honest adjusted result that shrinks it, and a fairness check on the model. Signal that this is where the numbers finally land. Transition: start with the headline anyone would compute first.</a:t>
             </a:r>
           </a:p>
         </p:txBody>
@@ -7724,8 +8048,8 @@
         </p:nvSpPr>
         <p:spPr>
           <a:xfrm>
-            <a:off x="457200" y="1143000"/>
-            <a:ext cx="3505200" cy="4846319"/>
+            <a:off x="457200" y="2423159"/>
+            <a:ext cx="3505200" cy="2468880"/>
           </a:xfrm>
           <a:prstGeom prst="rect">
             <a:avLst/>
@@ -7768,8 +8092,8 @@
         </p:nvSpPr>
         <p:spPr>
           <a:xfrm>
-            <a:off x="457200" y="1143000"/>
-            <a:ext cx="3505200" cy="54864"/>
+            <a:off x="457200" y="2423159"/>
+            <a:ext cx="3505200" cy="82296"/>
           </a:xfrm>
           <a:prstGeom prst="rect">
             <a:avLst/>
@@ -7812,8 +8136,8 @@
         </p:nvSpPr>
         <p:spPr>
           <a:xfrm>
-            <a:off x="621792" y="1234440"/>
-            <a:ext cx="3176016" cy="384048"/>
+            <a:off x="694944" y="2642615"/>
+            <a:ext cx="3029712" cy="365760"/>
           </a:xfrm>
           <a:prstGeom prst="rect">
             <a:avLst/>
@@ -7828,9 +8152,9 @@
           <a:p>
             <a:pPr algn="l"/>
             <a:r>
-              <a:rPr sz="1400" b="1" i="0">
-                <a:solidFill>
-                  <a:srgbClr val="40E0D0"/>
+              <a:rPr sz="1500" b="1" i="0">
+                <a:solidFill>
+                  <a:srgbClr val="0C7A6A"/>
                 </a:solidFill>
                 <a:latin typeface="Geist Mono"/>
               </a:rPr>
@@ -7847,8 +8171,8 @@
         </p:nvSpPr>
         <p:spPr>
           <a:xfrm>
-            <a:off x="621792" y="1783080"/>
-            <a:ext cx="3176016" cy="4114799"/>
+            <a:off x="694944" y="3191255"/>
+            <a:ext cx="3029712" cy="1572768"/>
           </a:xfrm>
           <a:prstGeom prst="rect">
             <a:avLst/>
@@ -7863,13 +8187,13 @@
           <a:p>
             <a:pPr algn="l"/>
             <a:r>
-              <a:rPr sz="1200" b="0" i="0">
+              <a:rPr sz="1400" b="0" i="0">
                 <a:solidFill>
                   <a:srgbClr val="14141C"/>
                 </a:solidFill>
                 <a:latin typeface="Geist"/>
               </a:rPr>
-              <a:t>Show a tempting headline is mostly a mirage, and that adjusting shrinks the effect by ~67%.</a:t>
+              <a:t>Show that a tempting headline is mostly a mirage, and that adjusting for background shrinks the apparent estrogen effect by about 67%.</a:t>
             </a:r>
           </a:p>
         </p:txBody>
@@ -7882,8 +8206,8 @@
         </p:nvSpPr>
         <p:spPr>
           <a:xfrm>
-            <a:off x="4328160" y="1143000"/>
-            <a:ext cx="3505200" cy="4846319"/>
+            <a:off x="4328160" y="2423159"/>
+            <a:ext cx="3505200" cy="2468880"/>
           </a:xfrm>
           <a:prstGeom prst="rect">
             <a:avLst/>
@@ -7926,8 +8250,8 @@
         </p:nvSpPr>
         <p:spPr>
           <a:xfrm>
-            <a:off x="4328160" y="1143000"/>
-            <a:ext cx="3505200" cy="54864"/>
+            <a:off x="4328160" y="2423159"/>
+            <a:ext cx="3505200" cy="82296"/>
           </a:xfrm>
           <a:prstGeom prst="rect">
             <a:avLst/>
@@ -7970,8 +8294,8 @@
         </p:nvSpPr>
         <p:spPr>
           <a:xfrm>
-            <a:off x="4492752" y="1234440"/>
-            <a:ext cx="3176016" cy="384048"/>
+            <a:off x="4565904" y="2642615"/>
+            <a:ext cx="3029712" cy="365760"/>
           </a:xfrm>
           <a:prstGeom prst="rect">
             <a:avLst/>
@@ -7986,7 +8310,7 @@
           <a:p>
             <a:pPr algn="l"/>
             <a:r>
-              <a:rPr sz="1400" b="1" i="0">
+              <a:rPr sz="1500" b="1" i="0">
                 <a:solidFill>
                   <a:srgbClr val="FF1493"/>
                 </a:solidFill>
@@ -8005,8 +8329,8 @@
         </p:nvSpPr>
         <p:spPr>
           <a:xfrm>
-            <a:off x="4492752" y="1783080"/>
-            <a:ext cx="3176016" cy="4114799"/>
+            <a:off x="4565904" y="3191255"/>
+            <a:ext cx="3029712" cy="1572768"/>
           </a:xfrm>
           <a:prstGeom prst="rect">
             <a:avLst/>
@@ -8021,13 +8345,13 @@
           <a:p>
             <a:pPr algn="l"/>
             <a:r>
-              <a:rPr sz="1200" b="0" i="0">
+              <a:rPr sz="1400" b="0" i="0">
                 <a:solidFill>
                   <a:srgbClr val="14141C"/>
                 </a:solidFill>
                 <a:latin typeface="Geist"/>
               </a:rPr>
-              <a:t>Prove cause. We can only correct for confounders we actually measured and thought of.</a:t>
+              <a:t>Prove cause. We can only correct for the confounders we actually measured and thought of -- something unrecorded could still be doing the work.</a:t>
             </a:r>
           </a:p>
         </p:txBody>
@@ -8040,8 +8364,8 @@
         </p:nvSpPr>
         <p:spPr>
           <a:xfrm>
-            <a:off x="8199120" y="1143000"/>
-            <a:ext cx="3505200" cy="4846319"/>
+            <a:off x="8199120" y="2423159"/>
+            <a:ext cx="3505200" cy="2468880"/>
           </a:xfrm>
           <a:prstGeom prst="rect">
             <a:avLst/>
@@ -8084,8 +8408,8 @@
         </p:nvSpPr>
         <p:spPr>
           <a:xfrm>
-            <a:off x="8199120" y="1143000"/>
-            <a:ext cx="3505200" cy="54864"/>
+            <a:off x="8199120" y="2423159"/>
+            <a:ext cx="3505200" cy="82296"/>
           </a:xfrm>
           <a:prstGeom prst="rect">
             <a:avLst/>
@@ -8128,8 +8452,8 @@
         </p:nvSpPr>
         <p:spPr>
           <a:xfrm>
-            <a:off x="8363712" y="1234440"/>
-            <a:ext cx="3176016" cy="384048"/>
+            <a:off x="8436864" y="2642615"/>
+            <a:ext cx="3029712" cy="365760"/>
           </a:xfrm>
           <a:prstGeom prst="rect">
             <a:avLst/>
@@ -8144,9 +8468,9 @@
           <a:p>
             <a:pPr algn="l"/>
             <a:r>
-              <a:rPr sz="1400" b="1" i="0">
-                <a:solidFill>
-                  <a:srgbClr val="F0C840"/>
+              <a:rPr sz="1500" b="1" i="0">
+                <a:solidFill>
+                  <a:srgbClr val="8A6D00"/>
                 </a:solidFill>
                 <a:latin typeface="Geist Mono"/>
               </a:rPr>
@@ -8163,8 +8487,8 @@
         </p:nvSpPr>
         <p:spPr>
           <a:xfrm>
-            <a:off x="8363712" y="1783080"/>
-            <a:ext cx="3176016" cy="4114799"/>
+            <a:off x="8436864" y="3191255"/>
+            <a:ext cx="3029712" cy="1572768"/>
           </a:xfrm>
           <a:prstGeom prst="rect">
             <a:avLst/>
@@ -8179,13 +8503,13 @@
           <a:p>
             <a:pPr algn="l"/>
             <a:r>
-              <a:rPr sz="1200" b="0" i="0">
+              <a:rPr sz="1400" b="0" i="0">
                 <a:solidFill>
                   <a:srgbClr val="14141C"/>
                 </a:solidFill>
                 <a:latin typeface="Geist"/>
               </a:rPr>
-              <a:t>A randomized trial: a coin flip, not the patient, assigns the drug. That is why WHIMS could overturn 20 years of headlines.</a:t>
+              <a:t>A randomized trial: a coin flip, not the patient, assigns the drug, so the two groups start out identical. That is why WHIMS could overturn 20 years of headlines.</a:t>
             </a:r>
           </a:p>
         </p:txBody>
@@ -8918,7 +9242,7 @@
         </p:nvSpPr>
         <p:spPr>
           <a:xfrm>
-            <a:off x="457200" y="1234440"/>
+            <a:off x="457200" y="1737360"/>
             <a:ext cx="146304" cy="2194560"/>
           </a:xfrm>
           <a:prstGeom prst="rect">
@@ -8962,7 +9286,7 @@
         </p:nvSpPr>
         <p:spPr>
           <a:xfrm>
-            <a:off x="914400" y="1234440"/>
+            <a:off x="914400" y="1737360"/>
             <a:ext cx="10698480" cy="1371600"/>
           </a:xfrm>
           <a:prstGeom prst="rect">
@@ -8997,7 +9321,7 @@
         </p:nvSpPr>
         <p:spPr>
           <a:xfrm>
-            <a:off x="914400" y="2743200"/>
+            <a:off x="914400" y="3291840"/>
             <a:ext cx="10332720" cy="1097280"/>
           </a:xfrm>
           <a:prstGeom prst="rect">
@@ -9032,7 +9356,7 @@
         </p:nvSpPr>
         <p:spPr>
           <a:xfrm>
-            <a:off x="914400" y="3886200"/>
+            <a:off x="914400" y="4526280"/>
             <a:ext cx="10332720" cy="731520"/>
           </a:xfrm>
           <a:prstGeom prst="rect">
@@ -10115,8 +10439,8 @@
         </p:nvSpPr>
         <p:spPr>
           <a:xfrm>
-            <a:off x="457200" y="1051560"/>
-            <a:ext cx="5440680" cy="4160519"/>
+            <a:off x="457200" y="1965960"/>
+            <a:ext cx="5394960" cy="2331720"/>
           </a:xfrm>
           <a:prstGeom prst="rect">
             <a:avLst/>
@@ -10159,8 +10483,8 @@
         </p:nvSpPr>
         <p:spPr>
           <a:xfrm>
-            <a:off x="457200" y="1051560"/>
-            <a:ext cx="5440680" cy="54864"/>
+            <a:off x="457200" y="1965960"/>
+            <a:ext cx="5394960" cy="82296"/>
           </a:xfrm>
           <a:prstGeom prst="rect">
             <a:avLst/>
@@ -10203,8 +10527,8 @@
         </p:nvSpPr>
         <p:spPr>
           <a:xfrm>
-            <a:off x="621792" y="1143000"/>
-            <a:ext cx="5111496" cy="384048"/>
+            <a:off x="713232" y="2185416"/>
+            <a:ext cx="4882896" cy="365760"/>
           </a:xfrm>
           <a:prstGeom prst="rect">
             <a:avLst/>
@@ -10219,9 +10543,9 @@
           <a:p>
             <a:pPr algn="l"/>
             <a:r>
-              <a:rPr sz="1400" b="1" i="0">
-                <a:solidFill>
-                  <a:srgbClr val="40E0D0"/>
+              <a:rPr sz="1500" b="1" i="0">
+                <a:solidFill>
+                  <a:srgbClr val="0C7A6A"/>
                 </a:solidFill>
                 <a:latin typeface="Geist Mono"/>
               </a:rPr>
@@ -10238,8 +10562,8 @@
         </p:nvSpPr>
         <p:spPr>
           <a:xfrm>
-            <a:off x="621792" y="1691640"/>
-            <a:ext cx="5111496" cy="3428999"/>
+            <a:off x="713232" y="2734056"/>
+            <a:ext cx="4882896" cy="1435607"/>
           </a:xfrm>
           <a:prstGeom prst="rect">
             <a:avLst/>
@@ -10254,13 +10578,13 @@
           <a:p>
             <a:pPr algn="l"/>
             <a:r>
-              <a:rPr sz="1200" b="0" i="0">
+              <a:rPr sz="1500" b="0" i="0">
                 <a:solidFill>
                   <a:srgbClr val="14141C"/>
                 </a:solidFill>
                 <a:latin typeface="Geist"/>
               </a:rPr>
-              <a:t>Studies that simply WATCHED women found that estrogen users developed Alzheimer's less often and later [1, 2]. It looked like solid proof the pills protected the brain.</a:t>
+              <a:t>Studies that simply WATCHED women found that estrogen users developed Alzheimer's less often, and later, than women who never took it [1, 2]. For years this looked like solid proof that the pills protected the aging brain.</a:t>
             </a:r>
           </a:p>
         </p:txBody>
@@ -10273,8 +10597,8 @@
         </p:nvSpPr>
         <p:spPr>
           <a:xfrm>
-            <a:off x="6263640" y="1051560"/>
-            <a:ext cx="5440680" cy="4160519"/>
+            <a:off x="6309360" y="1965960"/>
+            <a:ext cx="5394960" cy="2331720"/>
           </a:xfrm>
           <a:prstGeom prst="rect">
             <a:avLst/>
@@ -10317,8 +10641,8 @@
         </p:nvSpPr>
         <p:spPr>
           <a:xfrm>
-            <a:off x="6263640" y="1051560"/>
-            <a:ext cx="5440680" cy="54864"/>
+            <a:off x="6309360" y="1965960"/>
+            <a:ext cx="5394960" cy="82296"/>
           </a:xfrm>
           <a:prstGeom prst="rect">
             <a:avLst/>
@@ -10361,8 +10685,8 @@
         </p:nvSpPr>
         <p:spPr>
           <a:xfrm>
-            <a:off x="6428232" y="1143000"/>
-            <a:ext cx="5111496" cy="384048"/>
+            <a:off x="6565392" y="2185416"/>
+            <a:ext cx="4882896" cy="365760"/>
           </a:xfrm>
           <a:prstGeom prst="rect">
             <a:avLst/>
@@ -10377,7 +10701,7 @@
           <a:p>
             <a:pPr algn="l"/>
             <a:r>
-              <a:rPr sz="1400" b="1" i="0">
+              <a:rPr sz="1500" b="1" i="0">
                 <a:solidFill>
                   <a:srgbClr val="FF1493"/>
                 </a:solidFill>
@@ -10396,8 +10720,8 @@
         </p:nvSpPr>
         <p:spPr>
           <a:xfrm>
-            <a:off x="6428232" y="1691640"/>
-            <a:ext cx="5111496" cy="3428999"/>
+            <a:off x="6565392" y="2734056"/>
+            <a:ext cx="4882896" cy="1435607"/>
           </a:xfrm>
           <a:prstGeom prst="rect">
             <a:avLst/>
@@ -10412,13 +10736,13 @@
           <a:p>
             <a:pPr algn="l"/>
             <a:r>
-              <a:rPr sz="1200" b="0" i="0">
+              <a:rPr sz="1500" b="0" i="0">
                 <a:solidFill>
                   <a:srgbClr val="14141C"/>
                 </a:solidFill>
                 <a:latin typeface="Geist"/>
               </a:rPr>
-              <a:t>Then the WHIMS trial let a COIN FLIP decide who got hormones. The benefit vanished, and dementia risk actually ROSE in women 65+ [3, 4].</a:t>
+              <a:t>Then the WHIMS trial let a COIN FLIP -- not the woman herself -- decide who got hormones. The memory benefit vanished, and dementia risk actually ROSE in women aged 65 and older [3, 4].</a:t>
             </a:r>
           </a:p>
         </p:txBody>
@@ -10431,8 +10755,8 @@
         </p:nvSpPr>
         <p:spPr>
           <a:xfrm>
-            <a:off x="457200" y="5468112"/>
-            <a:ext cx="11247120" cy="566928"/>
+            <a:off x="457200" y="4663440"/>
+            <a:ext cx="11247120" cy="685800"/>
           </a:xfrm>
           <a:prstGeom prst="rect">
             <a:avLst/>
@@ -10475,8 +10799,8 @@
         </p:nvSpPr>
         <p:spPr>
           <a:xfrm>
-            <a:off x="685800" y="5468112"/>
-            <a:ext cx="10789920" cy="566928"/>
+            <a:off x="731520" y="4663440"/>
+            <a:ext cx="10698480" cy="685800"/>
           </a:xfrm>
           <a:prstGeom prst="rect">
             <a:avLst/>
@@ -10491,13 +10815,13 @@
           <a:p>
             <a:pPr algn="l"/>
             <a:r>
-              <a:rPr sz="1800" b="1" i="0">
+              <a:rPr sz="1900" b="1" i="0">
                 <a:solidFill>
                   <a:srgbClr val="14141C"/>
                 </a:solidFill>
                 <a:latin typeface="Geist Mono"/>
               </a:rPr>
-              <a:t>Same drug, opposite answer. The rest of this talk is one question: HOW?</a:t>
+              <a:t>Same drug, opposite answer. The rest of this talk is one question:  HOW?</a:t>
             </a:r>
           </a:p>
         </p:txBody>
@@ -10738,8 +11062,8 @@
         </p:blipFill>
         <p:spPr>
           <a:xfrm>
-            <a:off x="2285796" y="1097280"/>
-            <a:ext cx="7589926" cy="5120640"/>
+            <a:off x="2794050" y="1051560"/>
+            <a:ext cx="6573418" cy="4434840"/>
           </a:xfrm>
           <a:prstGeom prst="rect">
             <a:avLst/>
@@ -10754,8 +11078,8 @@
         </p:nvSpPr>
         <p:spPr>
           <a:xfrm>
-            <a:off x="457200" y="5989320"/>
-            <a:ext cx="11247120" cy="274320"/>
+            <a:off x="1371600" y="5715000"/>
+            <a:ext cx="9418320" cy="548640"/>
           </a:xfrm>
           <a:prstGeom prst="rect">
             <a:avLst/>
@@ -10770,13 +11094,13 @@
           <a:p>
             <a:pPr algn="ctr"/>
             <a:r>
-              <a:rPr sz="1300" b="0" i="1">
+              <a:rPr sz="1400" b="0" i="1">
                 <a:solidFill>
                   <a:srgbClr val="555560"/>
                 </a:solidFill>
                 <a:latin typeface="Geist"/>
               </a:rPr>
-              <a:t>Just watching (turquoise) said hormones protect; the coin-flip trial (pink) said they harm.</a:t>
+              <a:t>Just watching (turquoise) said hormones PROTECT; the coin-flip trial (pink) said they HARM -- the study design, not the drug, decided the answer.</a:t>
             </a:r>
           </a:p>
         </p:txBody>
@@ -11551,8 +11875,8 @@
         </p:nvSpPr>
         <p:spPr>
           <a:xfrm>
-            <a:off x="457200" y="1051560"/>
-            <a:ext cx="11247120" cy="502920"/>
+            <a:off x="457200" y="1143000"/>
+            <a:ext cx="11247120" cy="777240"/>
           </a:xfrm>
           <a:prstGeom prst="rect">
             <a:avLst/>
@@ -11567,7 +11891,7 @@
           <a:p>
             <a:pPr algn="l"/>
             <a:r>
-              <a:rPr sz="1700" b="0" i="0">
+              <a:rPr sz="1800" b="0" i="0">
                 <a:solidFill>
                   <a:srgbClr val="14141C"/>
                 </a:solidFill>
@@ -11586,8 +11910,8 @@
         </p:nvSpPr>
         <p:spPr>
           <a:xfrm>
-            <a:off x="457200" y="1737360"/>
-            <a:ext cx="5440680" cy="3428999"/>
+            <a:off x="457200" y="2011680"/>
+            <a:ext cx="5394960" cy="2286000"/>
           </a:xfrm>
           <a:prstGeom prst="rect">
             <a:avLst/>
@@ -11630,8 +11954,8 @@
         </p:nvSpPr>
         <p:spPr>
           <a:xfrm>
-            <a:off x="457200" y="1737360"/>
-            <a:ext cx="5440680" cy="54864"/>
+            <a:off x="457200" y="2011680"/>
+            <a:ext cx="5394960" cy="82296"/>
           </a:xfrm>
           <a:prstGeom prst="rect">
             <a:avLst/>
@@ -11674,8 +11998,8 @@
         </p:nvSpPr>
         <p:spPr>
           <a:xfrm>
-            <a:off x="621792" y="1828800"/>
-            <a:ext cx="5111496" cy="384048"/>
+            <a:off x="713232" y="2231136"/>
+            <a:ext cx="4882896" cy="365760"/>
           </a:xfrm>
           <a:prstGeom prst="rect">
             <a:avLst/>
@@ -11690,7 +12014,7 @@
           <a:p>
             <a:pPr algn="l"/>
             <a:r>
-              <a:rPr sz="1400" b="1" i="0">
+              <a:rPr sz="1500" b="1" i="0">
                 <a:solidFill>
                   <a:srgbClr val="8A2BE2"/>
                 </a:solidFill>
@@ -11709,8 +12033,8 @@
         </p:nvSpPr>
         <p:spPr>
           <a:xfrm>
-            <a:off x="621792" y="2377440"/>
-            <a:ext cx="5111496" cy="2697479"/>
+            <a:off x="713232" y="2779776"/>
+            <a:ext cx="4882896" cy="1389888"/>
           </a:xfrm>
           <a:prstGeom prst="rect">
             <a:avLst/>
@@ -11725,13 +12049,13 @@
           <a:p>
             <a:pPr algn="l"/>
             <a:r>
-              <a:rPr sz="1200" b="0" i="0">
+              <a:rPr sz="1500" b="0" i="0">
                 <a:solidFill>
                   <a:srgbClr val="14141C"/>
                 </a:solidFill>
                 <a:latin typeface="Geist"/>
               </a:rPr>
-              <a:t>No -- the hot SUMMER WEATHER drives both: heat sells ice cream and sends people into the ocean. Neither one causes the other.</a:t>
+              <a:t>No -- the hot SUMMER WEATHER drives both at once: heat sells more ice cream AND sends more people into the ocean to swim. Neither one causes the other.</a:t>
             </a:r>
           </a:p>
         </p:txBody>
@@ -11744,8 +12068,8 @@
         </p:nvSpPr>
         <p:spPr>
           <a:xfrm>
-            <a:off x="6263640" y="1737360"/>
-            <a:ext cx="5440680" cy="3428999"/>
+            <a:off x="6309360" y="2011680"/>
+            <a:ext cx="5394960" cy="2286000"/>
           </a:xfrm>
           <a:prstGeom prst="rect">
             <a:avLst/>
@@ -11788,8 +12112,8 @@
         </p:nvSpPr>
         <p:spPr>
           <a:xfrm>
-            <a:off x="6263640" y="1737360"/>
-            <a:ext cx="5440680" cy="54864"/>
+            <a:off x="6309360" y="2011680"/>
+            <a:ext cx="5394960" cy="82296"/>
           </a:xfrm>
           <a:prstGeom prst="rect">
             <a:avLst/>
@@ -11832,8 +12156,8 @@
         </p:nvSpPr>
         <p:spPr>
           <a:xfrm>
-            <a:off x="6428232" y="1828800"/>
-            <a:ext cx="5111496" cy="384048"/>
+            <a:off x="6565392" y="2231136"/>
+            <a:ext cx="4882896" cy="365760"/>
           </a:xfrm>
           <a:prstGeom prst="rect">
             <a:avLst/>
@@ -11848,9 +12172,9 @@
           <a:p>
             <a:pPr algn="l"/>
             <a:r>
-              <a:rPr sz="1400" b="1" i="0">
-                <a:solidFill>
-                  <a:srgbClr val="40E0D0"/>
+              <a:rPr sz="1500" b="1" i="0">
+                <a:solidFill>
+                  <a:srgbClr val="0C7A6A"/>
                 </a:solidFill>
                 <a:latin typeface="Geist Mono"/>
               </a:rPr>
@@ -11867,8 +12191,8 @@
         </p:nvSpPr>
         <p:spPr>
           <a:xfrm>
-            <a:off x="6428232" y="2377440"/>
-            <a:ext cx="5111496" cy="2697479"/>
+            <a:off x="6565392" y="2779776"/>
+            <a:ext cx="4882896" cy="1389888"/>
           </a:xfrm>
           <a:prstGeom prst="rect">
             <a:avLst/>
@@ -11883,13 +12207,13 @@
           <a:p>
             <a:pPr algn="l"/>
             <a:r>
-              <a:rPr sz="1200" b="0" i="0">
+              <a:rPr sz="1500" b="0" i="0">
                 <a:solidFill>
                   <a:srgbClr val="14141C"/>
                 </a:solidFill>
                 <a:latin typeface="Geist"/>
               </a:rPr>
-              <a:t>Estrogen use and good memory rise together. Being HEALTHIER to start with drives both -- the pill may summon nothing.</a:t>
+              <a:t>Estrogen use and good memory also rise together. But being HEALTHIER and better-off to start with can drive both -- so the pill itself may summon nothing.</a:t>
             </a:r>
           </a:p>
         </p:txBody>
@@ -11902,8 +12226,8 @@
         </p:nvSpPr>
         <p:spPr>
           <a:xfrm>
-            <a:off x="457200" y="5367527"/>
-            <a:ext cx="11247120" cy="502920"/>
+            <a:off x="457200" y="4681728"/>
+            <a:ext cx="11247120" cy="640080"/>
           </a:xfrm>
           <a:prstGeom prst="rect">
             <a:avLst/>
@@ -11911,14 +12235,14 @@
           <a:noFill/>
         </p:spPr>
         <p:txBody>
-          <a:bodyPr wrap="square" anchor="t" lIns="0" rIns="0" tIns="0" bIns="0">
+          <a:bodyPr wrap="square" anchor="ctr" lIns="0" rIns="0" tIns="0" bIns="0">
             <a:spAutoFit/>
           </a:bodyPr>
           <a:lstStyle/>
           <a:p>
             <a:pPr algn="l"/>
             <a:r>
-              <a:rPr sz="1500" b="1" i="0">
+              <a:rPr sz="1700" b="1" i="0">
                 <a:solidFill>
                   <a:srgbClr val="FF1493"/>
                 </a:solidFill>
@@ -12604,8 +12928,8 @@
         </p:nvSpPr>
         <p:spPr>
           <a:xfrm>
-            <a:off x="457200" y="1143000"/>
-            <a:ext cx="2571750" cy="4846319"/>
+            <a:off x="457200" y="2468879"/>
+            <a:ext cx="2592324" cy="2377440"/>
           </a:xfrm>
           <a:prstGeom prst="rect">
             <a:avLst/>
@@ -12648,8 +12972,8 @@
         </p:nvSpPr>
         <p:spPr>
           <a:xfrm>
-            <a:off x="457200" y="1143000"/>
-            <a:ext cx="2571750" cy="54864"/>
+            <a:off x="457200" y="2468879"/>
+            <a:ext cx="2592324" cy="82296"/>
           </a:xfrm>
           <a:prstGeom prst="rect">
             <a:avLst/>
@@ -12692,8 +13016,8 @@
         </p:nvSpPr>
         <p:spPr>
           <a:xfrm>
-            <a:off x="621792" y="1234440"/>
-            <a:ext cx="2242566" cy="384048"/>
+            <a:off x="658368" y="2670048"/>
+            <a:ext cx="2189988" cy="365760"/>
           </a:xfrm>
           <a:prstGeom prst="rect">
             <a:avLst/>
@@ -12710,7 +13034,7 @@
             <a:r>
               <a:rPr sz="1400" b="1" i="0">
                 <a:solidFill>
-                  <a:srgbClr val="40E0D0"/>
+                  <a:srgbClr val="0C7A6A"/>
                 </a:solidFill>
                 <a:latin typeface="Geist Mono"/>
               </a:rPr>
@@ -12727,8 +13051,8 @@
         </p:nvSpPr>
         <p:spPr>
           <a:xfrm>
-            <a:off x="621792" y="1783080"/>
-            <a:ext cx="2242566" cy="4114799"/>
+            <a:off x="658368" y="3200400"/>
+            <a:ext cx="2189988" cy="1536192"/>
           </a:xfrm>
           <a:prstGeom prst="rect">
             <a:avLst/>
@@ -12743,13 +13067,13 @@
           <a:p>
             <a:pPr algn="l"/>
             <a:r>
-              <a:rPr sz="1200" b="0" i="0">
+              <a:rPr sz="1400" b="0" i="0">
                 <a:solidFill>
                   <a:srgbClr val="14141C"/>
                 </a:solidFill>
                 <a:latin typeface="Geist"/>
               </a:rPr>
-              <a:t>all age 60+, drawn from the NHANES 2013-14 US national health survey.</a:t>
+              <a:t>all aged 60 or older, drawn from NHANES 2013-14 -- a real US government health survey, not data we made up.</a:t>
             </a:r>
           </a:p>
         </p:txBody>
@@ -12762,8 +13086,8 @@
         </p:nvSpPr>
         <p:spPr>
           <a:xfrm>
-            <a:off x="3348990" y="1143000"/>
-            <a:ext cx="2571750" cy="4846319"/>
+            <a:off x="3342132" y="2468879"/>
+            <a:ext cx="2592324" cy="2377440"/>
           </a:xfrm>
           <a:prstGeom prst="rect">
             <a:avLst/>
@@ -12806,8 +13130,8 @@
         </p:nvSpPr>
         <p:spPr>
           <a:xfrm>
-            <a:off x="3348990" y="1143000"/>
-            <a:ext cx="2571750" cy="54864"/>
+            <a:off x="3342132" y="2468879"/>
+            <a:ext cx="2592324" cy="82296"/>
           </a:xfrm>
           <a:prstGeom prst="rect">
             <a:avLst/>
@@ -12850,8 +13174,8 @@
         </p:nvSpPr>
         <p:spPr>
           <a:xfrm>
-            <a:off x="3513582" y="1234440"/>
-            <a:ext cx="2242566" cy="384048"/>
+            <a:off x="3543300" y="2670048"/>
+            <a:ext cx="2189988" cy="365760"/>
           </a:xfrm>
           <a:prstGeom prst="rect">
             <a:avLst/>
@@ -12885,8 +13209,8 @@
         </p:nvSpPr>
         <p:spPr>
           <a:xfrm>
-            <a:off x="3513582" y="1783080"/>
-            <a:ext cx="2242566" cy="4114799"/>
+            <a:off x="3543300" y="3200400"/>
+            <a:ext cx="2189988" cy="1536192"/>
           </a:xfrm>
           <a:prstGeom prst="rect">
             <a:avLst/>
@@ -12901,13 +13225,13 @@
           <a:p>
             <a:pPr algn="l"/>
             <a:r>
-              <a:rPr sz="1200" b="0" i="0">
+              <a:rPr sz="1400" b="0" i="0">
                 <a:solidFill>
                   <a:srgbClr val="14141C"/>
                 </a:solidFill>
                 <a:latin typeface="Geist"/>
               </a:rPr>
-              <a:t>whether she ever took female hormones -- yes or no, self-reported.</a:t>
+              <a:t>whether she ever took female hormones -- a simple yes or no, self-reported by each woman.</a:t>
             </a:r>
           </a:p>
         </p:txBody>
@@ -12920,8 +13244,8 @@
         </p:nvSpPr>
         <p:spPr>
           <a:xfrm>
-            <a:off x="6240780" y="1143000"/>
-            <a:ext cx="2571750" cy="4846319"/>
+            <a:off x="6227064" y="2468879"/>
+            <a:ext cx="2592324" cy="2377440"/>
           </a:xfrm>
           <a:prstGeom prst="rect">
             <a:avLst/>
@@ -12964,8 +13288,8 @@
         </p:nvSpPr>
         <p:spPr>
           <a:xfrm>
-            <a:off x="6240780" y="1143000"/>
-            <a:ext cx="2571750" cy="54864"/>
+            <a:off x="6227064" y="2468879"/>
+            <a:ext cx="2592324" cy="82296"/>
           </a:xfrm>
           <a:prstGeom prst="rect">
             <a:avLst/>
@@ -13008,8 +13332,8 @@
         </p:nvSpPr>
         <p:spPr>
           <a:xfrm>
-            <a:off x="6405372" y="1234440"/>
-            <a:ext cx="2242566" cy="384048"/>
+            <a:off x="6428231" y="2670048"/>
+            <a:ext cx="2189988" cy="365760"/>
           </a:xfrm>
           <a:prstGeom prst="rect">
             <a:avLst/>
@@ -13026,7 +13350,7 @@
             <a:r>
               <a:rPr sz="1400" b="1" i="0">
                 <a:solidFill>
-                  <a:srgbClr val="F0C840"/>
+                  <a:srgbClr val="8A6D00"/>
                 </a:solidFill>
                 <a:latin typeface="Geist Mono"/>
               </a:rPr>
@@ -13043,8 +13367,8 @@
         </p:nvSpPr>
         <p:spPr>
           <a:xfrm>
-            <a:off x="6405372" y="1783080"/>
-            <a:ext cx="2242566" cy="4114799"/>
+            <a:off x="6428231" y="3200400"/>
+            <a:ext cx="2189988" cy="1536192"/>
           </a:xfrm>
           <a:prstGeom prst="rect">
             <a:avLst/>
@@ -13059,13 +13383,13 @@
           <a:p>
             <a:pPr algn="l"/>
             <a:r>
-              <a:rPr sz="1200" b="0" i="0">
+              <a:rPr sz="1400" b="0" i="0">
                 <a:solidFill>
                   <a:srgbClr val="14141C"/>
                 </a:solidFill>
                 <a:latin typeface="Geist"/>
               </a:rPr>
-              <a:t>age, education, and family income -- the confounders we must check.</a:t>
+              <a:t>her age, education, and family income -- the confounders we have to account for.</a:t>
             </a:r>
           </a:p>
         </p:txBody>
@@ -13078,8 +13402,8 @@
         </p:nvSpPr>
         <p:spPr>
           <a:xfrm>
-            <a:off x="9132570" y="1143000"/>
-            <a:ext cx="2571750" cy="4846319"/>
+            <a:off x="9111996" y="2468879"/>
+            <a:ext cx="2592324" cy="2377440"/>
           </a:xfrm>
           <a:prstGeom prst="rect">
             <a:avLst/>
@@ -13122,8 +13446,8 @@
         </p:nvSpPr>
         <p:spPr>
           <a:xfrm>
-            <a:off x="9132570" y="1143000"/>
-            <a:ext cx="2571750" cy="54864"/>
+            <a:off x="9111996" y="2468879"/>
+            <a:ext cx="2592324" cy="82296"/>
           </a:xfrm>
           <a:prstGeom prst="rect">
             <a:avLst/>
@@ -13166,8 +13490,8 @@
         </p:nvSpPr>
         <p:spPr>
           <a:xfrm>
-            <a:off x="9297162" y="1234440"/>
-            <a:ext cx="2242566" cy="384048"/>
+            <a:off x="9313164" y="2670048"/>
+            <a:ext cx="2189988" cy="365760"/>
           </a:xfrm>
           <a:prstGeom prst="rect">
             <a:avLst/>
@@ -13201,8 +13525,8 @@
         </p:nvSpPr>
         <p:spPr>
           <a:xfrm>
-            <a:off x="9297162" y="1783080"/>
-            <a:ext cx="2242566" cy="4114799"/>
+            <a:off x="9313164" y="3200400"/>
+            <a:ext cx="2189988" cy="1536192"/>
           </a:xfrm>
           <a:prstGeom prst="rect">
             <a:avLst/>
@@ -13217,13 +13541,13 @@
           <a:p>
             <a:pPr algn="l"/>
             <a:r>
-              <a:rPr sz="1200" b="0" i="0">
+              <a:rPr sz="1400" b="0" i="0">
                 <a:solidFill>
                   <a:srgbClr val="14141C"/>
                 </a:solidFill>
                 <a:latin typeface="Geist"/>
               </a:rPr>
-              <a:t>a digit-symbol test; higher = sharper. We predict the weaker-scoring half.</a:t>
+              <a:t>a digit-symbol attention test; higher = sharper. Our model tries to flag the weaker-scoring half.</a:t>
             </a:r>
           </a:p>
         </p:txBody>
@@ -13457,7 +13781,7 @@
         <p:spPr>
           <a:xfrm>
             <a:off x="457200" y="1051560"/>
-            <a:ext cx="11247120" cy="502920"/>
+            <a:ext cx="11247120" cy="548640"/>
           </a:xfrm>
           <a:prstGeom prst="rect">
             <a:avLst/>
@@ -13472,13 +13796,13 @@
           <a:p>
             <a:pPr algn="l"/>
             <a:r>
-              <a:rPr sz="1800" b="0" i="0">
+              <a:rPr sz="1700" b="0" i="0">
                 <a:solidFill>
                   <a:srgbClr val="14141C"/>
                 </a:solidFill>
                 <a:latin typeface="Geist"/>
               </a:rPr>
-              <a:t>We cannot randomly assign estrogen in a survey. So we ask a narrower, honest question:</a:t>
+              <a:t>We cannot randomly ASSIGN estrogen in a survey -- so we can never prove cause here. But we can still ask a narrower, honest question:</a:t>
             </a:r>
           </a:p>
         </p:txBody>
@@ -13492,7 +13816,7 @@
         <p:spPr>
           <a:xfrm>
             <a:off x="457200" y="1737360"/>
-            <a:ext cx="11247120" cy="1051560"/>
+            <a:ext cx="11247120" cy="1005840"/>
           </a:xfrm>
           <a:prstGeom prst="rect">
             <a:avLst/>
@@ -13536,7 +13860,7 @@
         <p:spPr>
           <a:xfrm>
             <a:off x="457200" y="1737360"/>
-            <a:ext cx="128016" cy="1051560"/>
+            <a:ext cx="128016" cy="1005840"/>
           </a:xfrm>
           <a:prstGeom prst="rect">
             <a:avLst/>
@@ -13579,8 +13903,8 @@
         </p:nvSpPr>
         <p:spPr>
           <a:xfrm>
-            <a:off x="822960" y="1737360"/>
-            <a:ext cx="10607040" cy="1051560"/>
+            <a:off x="868680" y="1737360"/>
+            <a:ext cx="10561320" cy="1005840"/>
           </a:xfrm>
           <a:prstGeom prst="rect">
             <a:avLst/>
@@ -13614,8 +13938,8 @@
         </p:nvSpPr>
         <p:spPr>
           <a:xfrm>
-            <a:off x="457200" y="3108960"/>
-            <a:ext cx="5440680" cy="2606039"/>
+            <a:off x="457200" y="2971800"/>
+            <a:ext cx="5394960" cy="1600200"/>
           </a:xfrm>
           <a:prstGeom prst="rect">
             <a:avLst/>
@@ -13658,8 +13982,8 @@
         </p:nvSpPr>
         <p:spPr>
           <a:xfrm>
-            <a:off x="457200" y="3108960"/>
-            <a:ext cx="5440680" cy="54864"/>
+            <a:off x="457200" y="2971800"/>
+            <a:ext cx="5394960" cy="82296"/>
           </a:xfrm>
           <a:prstGeom prst="rect">
             <a:avLst/>
@@ -13702,8 +14026,8 @@
         </p:nvSpPr>
         <p:spPr>
           <a:xfrm>
-            <a:off x="621792" y="3200400"/>
-            <a:ext cx="5111496" cy="384048"/>
+            <a:off x="713232" y="3154680"/>
+            <a:ext cx="4882896" cy="365760"/>
           </a:xfrm>
           <a:prstGeom prst="rect">
             <a:avLst/>
@@ -13718,7 +14042,7 @@
           <a:p>
             <a:pPr algn="l"/>
             <a:r>
-              <a:rPr sz="1400" b="1" i="0">
+              <a:rPr sz="1500" b="1" i="0">
                 <a:solidFill>
                   <a:srgbClr val="FF1493"/>
                 </a:solidFill>
@@ -13737,8 +14061,8 @@
         </p:nvSpPr>
         <p:spPr>
           <a:xfrm>
-            <a:off x="621792" y="3749040"/>
-            <a:ext cx="5111496" cy="1874519"/>
+            <a:off x="713232" y="3648456"/>
+            <a:ext cx="4882896" cy="804672"/>
           </a:xfrm>
           <a:prstGeom prst="rect">
             <a:avLst/>
@@ -13753,13 +14077,13 @@
           <a:p>
             <a:pPr algn="l"/>
             <a:r>
-              <a:rPr sz="1200" b="0" i="0">
+              <a:rPr sz="1400" b="0" i="0">
                 <a:solidFill>
                   <a:srgbClr val="14141C"/>
                 </a:solidFill>
                 <a:latin typeface="Geist"/>
               </a:rPr>
-              <a:t>Estrogen's effect all by itself -- ignoring everything else about the woman.</a:t>
+              <a:t>Estrogen's effect measured all by itself -- ignoring everything else about the woman.</a:t>
             </a:r>
           </a:p>
         </p:txBody>
@@ -13772,8 +14096,8 @@
         </p:nvSpPr>
         <p:spPr>
           <a:xfrm>
-            <a:off x="6263640" y="3108960"/>
-            <a:ext cx="5440680" cy="2606039"/>
+            <a:off x="6309360" y="2971800"/>
+            <a:ext cx="5394960" cy="1600200"/>
           </a:xfrm>
           <a:prstGeom prst="rect">
             <a:avLst/>
@@ -13816,8 +14140,8 @@
         </p:nvSpPr>
         <p:spPr>
           <a:xfrm>
-            <a:off x="6263640" y="3108960"/>
-            <a:ext cx="5440680" cy="54864"/>
+            <a:off x="6309360" y="2971800"/>
+            <a:ext cx="5394960" cy="82296"/>
           </a:xfrm>
           <a:prstGeom prst="rect">
             <a:avLst/>
@@ -13860,8 +14184,8 @@
         </p:nvSpPr>
         <p:spPr>
           <a:xfrm>
-            <a:off x="6428232" y="3200400"/>
-            <a:ext cx="5111496" cy="384048"/>
+            <a:off x="6565392" y="3154680"/>
+            <a:ext cx="4882896" cy="365760"/>
           </a:xfrm>
           <a:prstGeom prst="rect">
             <a:avLst/>
@@ -13876,9 +14200,9 @@
           <a:p>
             <a:pPr algn="l"/>
             <a:r>
-              <a:rPr sz="1400" b="1" i="0">
-                <a:solidFill>
-                  <a:srgbClr val="40E0D0"/>
+              <a:rPr sz="1500" b="1" i="0">
+                <a:solidFill>
+                  <a:srgbClr val="0C7A6A"/>
                 </a:solidFill>
                 <a:latin typeface="Geist Mono"/>
               </a:rPr>
@@ -13895,8 +14219,8 @@
         </p:nvSpPr>
         <p:spPr>
           <a:xfrm>
-            <a:off x="6428232" y="3749040"/>
-            <a:ext cx="5111496" cy="1874519"/>
+            <a:off x="6565392" y="3648456"/>
+            <a:ext cx="4882896" cy="804672"/>
           </a:xfrm>
           <a:prstGeom prst="rect">
             <a:avLst/>
@@ -13911,13 +14235,13 @@
           <a:p>
             <a:pPr algn="l"/>
             <a:r>
-              <a:rPr sz="1200" b="0" i="0">
+              <a:rPr sz="1400" b="0" i="0">
                 <a:solidFill>
                   <a:srgbClr val="14141C"/>
                 </a:solidFill>
                 <a:latin typeface="Geist"/>
               </a:rPr>
-              <a:t>Estrogen's effect AFTER accounting for age, education, and income.</a:t>
+              <a:t>Estrogen's effect AFTER we account for her age, education, and income.</a:t>
             </a:r>
           </a:p>
         </p:txBody>
@@ -13930,8 +14254,8 @@
         </p:nvSpPr>
         <p:spPr>
           <a:xfrm>
-            <a:off x="457200" y="5879592"/>
-            <a:ext cx="11247120" cy="457200"/>
+            <a:off x="457200" y="4773168"/>
+            <a:ext cx="11247120" cy="502920"/>
           </a:xfrm>
           <a:prstGeom prst="rect">
             <a:avLst/>
@@ -13952,7 +14276,7 @@
                 </a:solidFill>
                 <a:latin typeface="Geist"/>
               </a:rPr>
-              <a:t>If the effect shrinks from crude to adjusted, the headline was mostly confounding -- not cause.</a:t>
+              <a:t>If the effect SHRINKS from crude to adjusted, the exciting headline was mostly confounding -- not real cause.</a:t>
             </a:r>
           </a:p>
         </p:txBody>

</xml_diff>